<commit_message>
Refactor thesis presentation scripts and add data preparation and verification tools
- Updated `build_thesis_pptx.py` to enhance presentation content with clearer experiment labels and results.
- Introduced `prepare_experiment_data.py` for downloading and normalizing public datasets, ensuring data availability for thesis verification.
- Created `run_all_thesis_experiments.py` to streamline the execution of all thesis-related experiments, including data preparation and result verification.
- Added `verify_thesis_results.py` to validate thesis results against computed evidence, generating comprehensive reports in JSON and Markdown formats.
</commit_message>
<xml_diff>
--- a/docs/papers/thesis/thesis_presentation_zh.pptx
+++ b/docs/papers/thesis/thesis_presentation_zh.pptx
@@ -21981,7 +21981,7 @@
                 </a:solidFill>
                 <a:latin typeface="PingFang TC"/>
               </a:rPr>
-              <a:t>synthetic full-field：8 組標準情境、truth-adjusted sensors、IDW 與消融</a:t>
+              <a:t>E1-E3：synthetic full-field、IDW baseline、ablation</a:t>
             </a:r>
           </a:p>
           <a:p>
@@ -22003,7 +22003,7 @@
                 </a:solidFill>
                 <a:latin typeface="PingFang TC"/>
               </a:rPr>
-              <a:t>hybrid residual：no-Fourier 對照與 LOO cross-validation</a:t>
+              <a:t>E4：非連網裝置影響學習與推薦排序</a:t>
             </a:r>
           </a:p>
           <a:p>
@@ -22025,7 +22025,7 @@
                 </a:solidFill>
                 <a:latin typeface="PingFang TC"/>
               </a:rPr>
-              <a:t>window matrix：48 組外部邊界條件敏感度</a:t>
+              <a:t>E5：window matrix 48 組外部邊界條件</a:t>
             </a:r>
           </a:p>
           <a:p>
@@ -22047,7 +22047,7 @@
                 </a:solidFill>
                 <a:latin typeface="PingFang TC"/>
               </a:rPr>
-              <a:t>真實 bedroom_01 快照：28 筆，檢查 pillow 位置</a:t>
+              <a:t>E6：hybrid no-Fourier 對照與 LOO cross-validation</a:t>
             </a:r>
           </a:p>
           <a:p>
@@ -22069,7 +22069,7 @@
                 </a:solidFill>
                 <a:latin typeface="PingFang TC"/>
               </a:rPr>
-              <a:t>public datasets：只作 task-aligned benchmark，不當 full-field 基準</a:t>
+              <a:t>E7：bedroom_01 28 筆，pillow hold-out</a:t>
             </a:r>
           </a:p>
           <a:p>
@@ -22091,7 +22091,7 @@
                 </a:solidFill>
                 <a:latin typeface="PingFang TC"/>
               </a:rPr>
-              <a:t>推薦排序：目前是 counterfactual simulation；有效性需介入實驗</a:t>
+              <a:t>E8 protocol、E9 public benchmark；demo 不是量化實驗</a:t>
             </a:r>
           </a:p>
         </p:txBody>

</xml_diff>

<commit_message>
Refactor MCP server and Gemma bridge tools for enhanced functionality
- Updated the MCP server to include new tools: initialize_environment, rank_actions, and learn_impacts, while removing deprecated tools.
- Enhanced the initialize_environment tool to register devices and furniture with specified parameters.
- Modified the sample_point tool to accept both elapsed time and steady state inputs.
- Adjusted the learn_impacts tool to handle before and after observations for non-networked devices.
- Updated unit tests to reflect changes in tool names and functionalities, ensuring proper coverage for new features.
- Improved documentation and comments for clarity on tool usage and expected parameters.
</commit_message>
<xml_diff>
--- a/docs/papers/thesis/thesis_presentation_zh.pptx
+++ b/docs/papers/thesis/thesis_presentation_zh.pptx
@@ -18487,7 +18487,7 @@
                 </a:solidFill>
                 <a:latin typeface="PingFang TC"/>
               </a:rPr>
-              <a:t>溫度/濕度可做 Fourier low-pass；照度保留快速跳變</a:t>
+              <a:t>溫濕度響應較平滑可低通；照度因光源/遮蔽需保留快速跳變</a:t>
             </a:r>
           </a:p>
         </p:txBody>
@@ -21402,73 +21402,139 @@
                 </a:solidFill>
                 <a:latin typeface="PingFang TC"/>
               </a:rPr>
-              <a:t>MCP / Gemma</a:t>
-            </a:r>
-          </a:p>
-          <a:p>
-            <a:pPr>
-              <a:spcAft>
-                <a:spcPts val="300"/>
-              </a:spcAft>
-              <a:defRPr sz="1200">
-                <a:solidFill>
-                  <a:srgbClr val="192028"/>
-                </a:solidFill>
-                <a:latin typeface="PingFang TC"/>
-              </a:defRPr>
-            </a:pPr>
-            <a:r>
-              <a:rPr sz="1200" b="0">
-                <a:solidFill>
-                  <a:srgbClr val="192028"/>
-                </a:solidFill>
-                <a:latin typeface="PingFang TC"/>
-              </a:rPr>
-              <a:t>本地 stdio MCP server</a:t>
-            </a:r>
-          </a:p>
-          <a:p>
-            <a:pPr>
-              <a:spcAft>
-                <a:spcPts val="300"/>
-              </a:spcAft>
-              <a:defRPr sz="1200">
-                <a:solidFill>
-                  <a:srgbClr val="192028"/>
-                </a:solidFill>
-                <a:latin typeface="PingFang TC"/>
-              </a:defRPr>
-            </a:pPr>
-            <a:r>
-              <a:rPr sz="1200" b="0">
-                <a:solidFill>
-                  <a:srgbClr val="192028"/>
-                </a:solidFill>
-                <a:latin typeface="PingFang TC"/>
-              </a:rPr>
-              <a:t>提供 scenario, ranking, point sample, baseline, impacts, window tools</a:t>
-            </a:r>
-          </a:p>
-          <a:p>
-            <a:pPr>
-              <a:spcAft>
-                <a:spcPts val="300"/>
-              </a:spcAft>
-              <a:defRPr sz="1200">
-                <a:solidFill>
-                  <a:srgbClr val="192028"/>
-                </a:solidFill>
-                <a:latin typeface="PingFang TC"/>
-              </a:defRPr>
-            </a:pPr>
-            <a:r>
-              <a:rPr sz="1200" b="0">
-                <a:solidFill>
-                  <a:srgbClr val="192028"/>
-                </a:solidFill>
-                <a:latin typeface="PingFang TC"/>
-              </a:rPr>
-              <a:t>Gemma 透過 bridge 做 tool calling</a:t>
+              <a:t>MCP：工具化介面</a:t>
+            </a:r>
+          </a:p>
+          <a:p>
+            <a:pPr>
+              <a:spcAft>
+                <a:spcPts val="300"/>
+              </a:spcAft>
+              <a:defRPr sz="1200">
+                <a:solidFill>
+                  <a:srgbClr val="192028"/>
+                </a:solidFill>
+                <a:latin typeface="PingFang TC"/>
+              </a:defRPr>
+            </a:pPr>
+            <a:r>
+              <a:rPr sz="1200" b="0">
+                <a:solidFill>
+                  <a:srgbClr val="192028"/>
+                </a:solidFill>
+                <a:latin typeface="PingFang TC"/>
+              </a:rPr>
+              <a:t>MCP 不做預測；只提供 AI 可呼叫 runtime tools</a:t>
+            </a:r>
+          </a:p>
+          <a:p>
+            <a:pPr>
+              <a:spcAft>
+                <a:spcPts val="300"/>
+              </a:spcAft>
+              <a:defRPr sz="1200">
+                <a:solidFill>
+                  <a:srgbClr val="192028"/>
+                </a:solidFill>
+                <a:latin typeface="PingFang TC"/>
+              </a:defRPr>
+            </a:pPr>
+            <a:r>
+              <a:rPr sz="1200" b="0">
+                <a:solidFill>
+                  <a:srgbClr val="192028"/>
+                </a:solidFill>
+                <a:latin typeface="PingFang TC"/>
+              </a:rPr>
+              <a:t>initialize：註冊環境、設備、家具與 baseline</a:t>
+            </a:r>
+          </a:p>
+          <a:p>
+            <a:pPr>
+              <a:spcAft>
+                <a:spcPts val="300"/>
+              </a:spcAft>
+              <a:defRPr sz="1200">
+                <a:solidFill>
+                  <a:srgbClr val="192028"/>
+                </a:solidFill>
+                <a:latin typeface="PingFang TC"/>
+              </a:defRPr>
+            </a:pPr>
+            <a:r>
+              <a:rPr sz="1200" b="0">
+                <a:solidFill>
+                  <a:srgbClr val="192028"/>
+                </a:solidFill>
+                <a:latin typeface="PingFang TC"/>
+              </a:rPr>
+              <a:t>sample point：查指定座標在特定時間/穩定態的三因子</a:t>
+            </a:r>
+          </a:p>
+          <a:p>
+            <a:pPr>
+              <a:spcAft>
+                <a:spcPts val="300"/>
+              </a:spcAft>
+              <a:defRPr sz="1200">
+                <a:solidFill>
+                  <a:srgbClr val="192028"/>
+                </a:solidFill>
+                <a:latin typeface="PingFang TC"/>
+              </a:defRPr>
+            </a:pPr>
+            <a:r>
+              <a:rPr sz="1200" b="0">
+                <a:solidFill>
+                  <a:srgbClr val="192028"/>
+                </a:solidFill>
+                <a:latin typeface="PingFang TC"/>
+              </a:rPr>
+              <a:t>learn impacts：建立 before/after 觀測紀錄再學係數</a:t>
+            </a:r>
+          </a:p>
+          <a:p>
+            <a:pPr>
+              <a:spcAft>
+                <a:spcPts val="300"/>
+              </a:spcAft>
+              <a:defRPr sz="1200">
+                <a:solidFill>
+                  <a:srgbClr val="192028"/>
+                </a:solidFill>
+                <a:latin typeface="PingFang TC"/>
+              </a:defRPr>
+            </a:pPr>
+            <a:r>
+              <a:rPr sz="1200" b="0">
+                <a:solidFill>
+                  <a:srgbClr val="192028"/>
+                </a:solidFill>
+                <a:latin typeface="PingFang TC"/>
+              </a:rPr>
+              <a:t>window direct：直接輸入外部溫濕度、日照與開窗比例</a:t>
+            </a:r>
+          </a:p>
+          <a:p>
+            <a:pPr>
+              <a:spcAft>
+                <a:spcPts val="300"/>
+              </a:spcAft>
+              <a:defRPr sz="1200">
+                <a:solidFill>
+                  <a:srgbClr val="192028"/>
+                </a:solidFill>
+                <a:latin typeface="PingFang TC"/>
+              </a:defRPr>
+            </a:pPr>
+            <a:r>
+              <a:rPr sz="1200" b="0">
+                <a:solidFill>
+                  <a:srgbClr val="192028"/>
+                </a:solidFill>
+                <a:latin typeface="PingFang TC"/>
+              </a:rPr>
+              <a:t>rank actions：針對指定座標與目標排序註冊設備操作</a:t>
             </a:r>
           </a:p>
         </p:txBody>

</xml_diff>

<commit_message>
Refactor presentation slides: update titles and content for sensor calibration and learning to model learning, inference, and recommendation flow; adjust associated images and bullet points for clarity and consistency.
</commit_message>
<xml_diff>
--- a/docs/papers/thesis/thesis_presentation_zh.pptx
+++ b/docs/papers/thesis/thesis_presentation_zh.pptx
@@ -21063,14 +21063,14 @@
                 </a:solidFill>
                 <a:latin typeface="PingFang TC"/>
               </a:rPr>
-              <a:t>感測器校正與影響學習</a:t>
+              <a:t>模型學習、推論與推薦資料流</a:t>
             </a:r>
           </a:p>
         </p:txBody>
       </p:sp>
       <p:pic>
         <p:nvPicPr>
-          <p:cNvPr id="4" name="Picture 3" descr="感測器校正與學習流程.png"/>
+          <p:cNvPr id="4" name="Picture 3" descr="模型學習推論與推薦資料流.png"/>
           <p:cNvPicPr>
             <a:picLocks noChangeAspect="1"/>
           </p:cNvPicPr>
@@ -21084,8 +21084,8 @@
         </p:blipFill>
         <p:spPr>
           <a:xfrm>
-            <a:off x="640080" y="1234440"/>
-            <a:ext cx="5760720" cy="4800600"/>
+            <a:off x="411480" y="1024128"/>
+            <a:ext cx="11384280" cy="5230368"/>
           </a:xfrm>
           <a:prstGeom prst="rect">
             <a:avLst/>
@@ -21095,117 +21095,6 @@
       <p:sp>
         <p:nvSpPr>
           <p:cNvPr id="5" name="TextBox 4"/>
-          <p:cNvSpPr txBox="1"/>
-          <p:nvPr/>
-        </p:nvSpPr>
-        <p:spPr>
-          <a:xfrm>
-            <a:off x="6583680" y="1417320"/>
-            <a:ext cx="4572000" cy="4572000"/>
-          </a:xfrm>
-          <a:prstGeom prst="rect">
-            <a:avLst/>
-          </a:prstGeom>
-          <a:noFill/>
-        </p:spPr>
-        <p:txBody>
-          <a:bodyPr wrap="square">
-            <a:spAutoFit/>
-          </a:bodyPr>
-          <a:lstStyle/>
-          <a:p>
-            <a:pPr>
-              <a:spcAft>
-                <a:spcPts val="800"/>
-              </a:spcAft>
-              <a:defRPr sz="1700">
-                <a:solidFill>
-                  <a:srgbClr val="192028"/>
-                </a:solidFill>
-                <a:latin typeface="PingFang TC"/>
-              </a:defRPr>
-            </a:pPr>
-            <a:r>
-              <a:rPr sz="1700" b="0">
-                <a:solidFill>
-                  <a:srgbClr val="192028"/>
-                </a:solidFill>
-                <a:latin typeface="PingFang TC"/>
-              </a:rPr>
-              <a:t>先用 8 顆角落感測器比較預測值與觀測值</a:t>
-            </a:r>
-          </a:p>
-          <a:p>
-            <a:pPr>
-              <a:spcAft>
-                <a:spcPts val="800"/>
-              </a:spcAft>
-              <a:defRPr sz="1700">
-                <a:solidFill>
-                  <a:srgbClr val="192028"/>
-                </a:solidFill>
-                <a:latin typeface="PingFang TC"/>
-              </a:defRPr>
-            </a:pPr>
-            <a:r>
-              <a:rPr sz="1700" b="0">
-                <a:solidFill>
-                  <a:srgbClr val="192028"/>
-                </a:solidFill>
-                <a:latin typeface="PingFang TC"/>
-              </a:rPr>
-              <a:t>用殘差校準 active device power scale</a:t>
-            </a:r>
-          </a:p>
-          <a:p>
-            <a:pPr>
-              <a:spcAft>
-                <a:spcPts val="800"/>
-              </a:spcAft>
-              <a:defRPr sz="1700">
-                <a:solidFill>
-                  <a:srgbClr val="192028"/>
-                </a:solidFill>
-                <a:latin typeface="PingFang TC"/>
-              </a:defRPr>
-            </a:pPr>
-            <a:r>
-              <a:rPr sz="1700" b="0">
-                <a:solidFill>
-                  <a:srgbClr val="192028"/>
-                </a:solidFill>
-                <a:latin typeface="PingFang TC"/>
-              </a:rPr>
-              <a:t>再擬合 trilinear residual correction</a:t>
-            </a:r>
-          </a:p>
-          <a:p>
-            <a:pPr>
-              <a:spcAft>
-                <a:spcPts val="800"/>
-              </a:spcAft>
-              <a:defRPr sz="1700">
-                <a:solidFill>
-                  <a:srgbClr val="192028"/>
-                </a:solidFill>
-                <a:latin typeface="PingFang TC"/>
-              </a:defRPr>
-            </a:pPr>
-            <a:r>
-              <a:rPr sz="1700" b="0">
-                <a:solidFill>
-                  <a:srgbClr val="192028"/>
-                </a:solidFill>
-                <a:latin typeface="PingFang TC"/>
-              </a:rPr>
-              <a:t>before/after observations 另外用來學非連網裝置影響係數</a:t>
-            </a:r>
-          </a:p>
-        </p:txBody>
-      </p:sp>
-      <p:sp>
-        <p:nvSpPr>
-          <p:cNvPr id="6" name="TextBox 5"/>
           <p:cNvSpPr txBox="1"/>
           <p:nvPr/>
         </p:nvSpPr>
@@ -21446,7 +21335,7 @@
                 </a:solidFill>
                 <a:latin typeface="PingFang TC"/>
               </a:rPr>
-              <a:t>initialize：註冊環境、設備、家具與 baseline</a:t>
+              <a:t>initialize：設定 scenario、baseline、外部邊界、設備/家具、時間與 estimator</a:t>
             </a:r>
           </a:p>
           <a:p>

</xml_diff>

<commit_message>
feat: Enhance thesis presentation and public benchmark integration
- Added new slides for public benchmark task breakdowns (SML2010 and CU-BEMS) in the thesis presentation.
- Updated existing slides with refined bullet points and improved clarity.
- Introduced a new directory for public benchmark figures and modified the presentation script to include these figures.
- Enhanced the `run_all_thesis_experiments.py` script to check for public comparison outputs and generate figures accordingly.
- Updated tests in `test_gemma_bridge.py` and `test_mcp_server.py` to validate new target parameters for the rank actions tool.
- Ensured that the rank actions tool requires complete target information and added corresponding error handling in tests.
</commit_message>
<xml_diff>
--- a/docs/papers/thesis/thesis_presentation_zh.pptx
+++ b/docs/papers/thesis/thesis_presentation_zh.pptx
@@ -20923,7 +20923,7 @@
                 </a:solidFill>
                 <a:latin typeface="PingFang TC"/>
               </a:rPr>
-              <a:t>控制推薦在 target zone 上評分與排序</a:t>
+              <a:t>推薦必須先有 sample / cluster 與三因子目標</a:t>
             </a:r>
           </a:p>
         </p:txBody>
@@ -21423,7 +21423,7 @@
                 </a:solidFill>
                 <a:latin typeface="PingFang TC"/>
               </a:rPr>
-              <a:t>rank actions：針對指定座標與目標排序註冊設備操作</a:t>
+              <a:t>rank actions：指定座標 sample + T/H/L 目標後才排序註冊設備操作</a:t>
             </a:r>
           </a:p>
         </p:txBody>

</xml_diff>

<commit_message>
Refactor system architecture representation and update related documentation
- Updated figure caption in IEEE paper to reflect new terminology for the architecture diagram.
- Modified architecture diagram to represent a top-down abstraction tree structure.
- Adjusted references and descriptions in thesis documents to align with the new architecture representation.
- Enhanced the build script for architecture diagrams to generate the updated SVG format.
- Added unit tests to validate the rendering of the system abstraction tree in SVG format.
</commit_message>
<xml_diff>
--- a/docs/papers/thesis/thesis_presentation_zh.pptx
+++ b/docs/papers/thesis/thesis_presentation_zh.pptx
@@ -3434,8 +3434,8 @@
         </p:blipFill>
         <p:spPr>
           <a:xfrm>
-            <a:off x="6126480" y="2080618"/>
-            <a:ext cx="5120640" cy="2971083"/>
+            <a:off x="6126480" y="2132561"/>
+            <a:ext cx="5120640" cy="2867197"/>
           </a:xfrm>
           <a:prstGeom prst="rect">
             <a:avLst/>
@@ -23331,8 +23331,8 @@
         </p:blipFill>
         <p:spPr>
           <a:xfrm>
-            <a:off x="731520" y="2065948"/>
-            <a:ext cx="5486400" cy="3183303"/>
+            <a:off x="731520" y="2121601"/>
+            <a:ext cx="5486400" cy="3071997"/>
           </a:xfrm>
           <a:prstGeom prst="rect">
             <a:avLst/>
@@ -23366,23 +23366,23 @@
                 <a:spcPct val="112000"/>
               </a:lnSpc>
               <a:spcAft>
-                <a:spcPts val="765"/>
+                <a:spcPts val="720"/>
               </a:spcAft>
-              <a:defRPr sz="1700">
-                <a:solidFill>
-                  <a:srgbClr val="1E2733"/>
-                </a:solidFill>
-                <a:latin typeface="Noto Sans TC"/>
-              </a:defRPr>
-            </a:pPr>
-            <a:r>
-              <a:rPr sz="1700" b="0">
-                <a:solidFill>
-                  <a:srgbClr val="1E2733"/>
-                </a:solidFill>
-                <a:latin typeface="Noto Sans TC"/>
-              </a:rPr>
-              <a:t>• 入口分成使用者互動層與 AI 工具呼叫層</a:t>
+              <a:defRPr sz="1600">
+                <a:solidFill>
+                  <a:srgbClr val="1E2733"/>
+                </a:solidFill>
+                <a:latin typeface="Noto Sans TC"/>
+              </a:defRPr>
+            </a:pPr>
+            <a:r>
+              <a:rPr sz="1600" b="0">
+                <a:solidFill>
+                  <a:srgbClr val="1E2733"/>
+                </a:solidFill>
+                <a:latin typeface="Noto Sans TC"/>
+              </a:rPr>
+              <a:t>• top-down tree 先區分三個責任域</a:t>
             </a:r>
           </a:p>
           <a:p>
@@ -23391,23 +23391,23 @@
                 <a:spcPct val="112000"/>
               </a:lnSpc>
               <a:spcAft>
-                <a:spcPts val="765"/>
+                <a:spcPts val="720"/>
               </a:spcAft>
-              <a:defRPr sz="1700">
-                <a:solidFill>
-                  <a:srgbClr val="1E2733"/>
-                </a:solidFill>
-                <a:latin typeface="Noto Sans TC"/>
-              </a:defRPr>
-            </a:pPr>
-            <a:r>
-              <a:rPr sz="1700" b="0">
-                <a:solidFill>
-                  <a:srgbClr val="1E2733"/>
-                </a:solidFill>
-                <a:latin typeface="Noto Sans TC"/>
-              </a:rPr>
-              <a:t>• 所有請求都先進入服務編排層</a:t>
+              <a:defRPr sz="1600">
+                <a:solidFill>
+                  <a:srgbClr val="1E2733"/>
+                </a:solidFill>
+                <a:latin typeface="Noto Sans TC"/>
+              </a:defRPr>
+            </a:pPr>
+            <a:r>
+              <a:rPr sz="1600" b="0">
+                <a:solidFill>
+                  <a:srgbClr val="1E2733"/>
+                </a:solidFill>
+                <a:latin typeface="Noto Sans TC"/>
+              </a:rPr>
+              <a:t>• 情境與觀測層整理房間、8 點感測與外部邊界</a:t>
             </a:r>
           </a:p>
           <a:p>
@@ -23416,23 +23416,23 @@
                 <a:spcPct val="112000"/>
               </a:lnSpc>
               <a:spcAft>
-                <a:spcPts val="765"/>
+                <a:spcPts val="720"/>
               </a:spcAft>
-              <a:defRPr sz="1700">
-                <a:solidFill>
-                  <a:srgbClr val="1E2733"/>
-                </a:solidFill>
-                <a:latin typeface="Noto Sans TC"/>
-              </a:defRPr>
-            </a:pPr>
-            <a:r>
-              <a:rPr sz="1700" b="0">
-                <a:solidFill>
-                  <a:srgbClr val="1E2733"/>
-                </a:solidFill>
-                <a:latin typeface="Noto Sans TC"/>
-              </a:rPr>
-              <a:t>• 後端主體為環境數位孿生核心與校正學習層</a:t>
+              <a:defRPr sz="1600">
+                <a:solidFill>
+                  <a:srgbClr val="1E2733"/>
+                </a:solidFill>
+                <a:latin typeface="Noto Sans TC"/>
+              </a:defRPr>
+            </a:pPr>
+            <a:r>
+              <a:rPr sz="1600" b="0">
+                <a:solidFill>
+                  <a:srgbClr val="1E2733"/>
+                </a:solidFill>
+                <a:latin typeface="Noto Sans TC"/>
+              </a:rPr>
+              <a:t>• 估測與學習層負責 T/H/L field model、校正與 residual</a:t>
             </a:r>
           </a:p>
           <a:p>
@@ -23441,23 +23441,23 @@
                 <a:spcPct val="112000"/>
               </a:lnSpc>
               <a:spcAft>
-                <a:spcPts val="765"/>
+                <a:spcPts val="720"/>
               </a:spcAft>
-              <a:defRPr sz="1700">
-                <a:solidFill>
-                  <a:srgbClr val="1E2733"/>
-                </a:solidFill>
-                <a:latin typeface="Noto Sans TC"/>
-              </a:defRPr>
-            </a:pPr>
-            <a:r>
-              <a:rPr sz="1700" b="0">
-                <a:solidFill>
-                  <a:srgbClr val="1E2733"/>
-                </a:solidFill>
-                <a:latin typeface="Noto Sans TC"/>
-              </a:rPr>
-              <a:t>• hybrid residual 只作為 optional 第二層修正器</a:t>
+              <a:defRPr sz="1600">
+                <a:solidFill>
+                  <a:srgbClr val="1E2733"/>
+                </a:solidFill>
+                <a:latin typeface="Noto Sans TC"/>
+              </a:defRPr>
+            </a:pPr>
+            <a:r>
+              <a:rPr sz="1600" b="0">
+                <a:solidFill>
+                  <a:srgbClr val="1E2733"/>
+                </a:solidFill>
+                <a:latin typeface="Noto Sans TC"/>
+              </a:rPr>
+              <a:t>• 服務與決策層才包含 scripts、Web、MCP/Gemma 與 action ranking</a:t>
             </a:r>
           </a:p>
         </p:txBody>

</xml_diff>